<commit_message>
fix: pied de page Developed, titre p.3 reformule, PDF et captures regeneres
- Fonds des 4 pages corriges (Developped -> Developed), sources PowerPoint dans Design/
- p.3 : 'Most of our customers are maried' -> 'Married customers are our largest group' (863 / 2 239 = 39 %)
- PDF reexporte, captures regenerees depuis le PDF (1937 px)
</commit_message>
<xml_diff>
--- a/Design/buyer-composition-background.pptx
+++ b/Design/buyer-composition-background.pptx
@@ -8,6 +8,7 @@
     <p:sldId id="256" r:id="rId2"/>
     <p:sldId id="257" r:id="rId3"/>
     <p:sldId id="258" r:id="rId4"/>
+    <p:sldId id="259" r:id="rId5"/>
   </p:sldIdLst>
   <p:sldSz cx="12192000" cy="6858000"/>
   <p:notesSz cx="6858000" cy="9144000"/>
@@ -106,6 +107,11 @@
       </a:defRPr>
     </a:lvl9pPr>
   </p:defaultTextStyle>
+  <p:extLst>
+    <p:ext uri="{EFAFB233-063F-42B5-8137-9DF3F51BA10A}">
+      <p15:sldGuideLst xmlns:p15="http://schemas.microsoft.com/office/powerpoint/2012/main"/>
+    </p:ext>
+  </p:extLst>
 </p:presentation>
 </file>
 
@@ -305,7 +311,7 @@
           <a:p>
             <a:fld id="{BC070D19-CEA5-4277-916F-A68997455471}" type="datetimeFigureOut">
               <a:rPr lang="fr-FR" smtClean="0"/>
-              <a:t>06/11/2024</a:t>
+              <a:t>09/10/2026</a:t>
             </a:fld>
             <a:endParaRPr lang="fr-FR"/>
           </a:p>
@@ -586,7 +592,7 @@
           <a:p>
             <a:fld id="{BC070D19-CEA5-4277-916F-A68997455471}" type="datetimeFigureOut">
               <a:rPr lang="fr-FR" smtClean="0"/>
-              <a:t>06/11/2024</a:t>
+              <a:t>09/10/2026</a:t>
             </a:fld>
             <a:endParaRPr lang="fr-FR"/>
           </a:p>
@@ -778,7 +784,7 @@
           <a:p>
             <a:fld id="{BC070D19-CEA5-4277-916F-A68997455471}" type="datetimeFigureOut">
               <a:rPr lang="fr-FR" smtClean="0"/>
-              <a:t>06/11/2024</a:t>
+              <a:t>09/10/2026</a:t>
             </a:fld>
             <a:endParaRPr lang="fr-FR"/>
           </a:p>
@@ -1039,7 +1045,7 @@
           <a:p>
             <a:fld id="{BC070D19-CEA5-4277-916F-A68997455471}" type="datetimeFigureOut">
               <a:rPr lang="fr-FR" smtClean="0"/>
-              <a:t>06/11/2024</a:t>
+              <a:t>09/10/2026</a:t>
             </a:fld>
             <a:endParaRPr lang="fr-FR"/>
           </a:p>
@@ -1465,7 +1471,7 @@
           <a:p>
             <a:fld id="{BC070D19-CEA5-4277-916F-A68997455471}" type="datetimeFigureOut">
               <a:rPr lang="fr-FR" smtClean="0"/>
-              <a:t>06/11/2024</a:t>
+              <a:t>09/10/2026</a:t>
             </a:fld>
             <a:endParaRPr lang="fr-FR"/>
           </a:p>
@@ -2011,7 +2017,7 @@
           <a:p>
             <a:fld id="{BC070D19-CEA5-4277-916F-A68997455471}" type="datetimeFigureOut">
               <a:rPr lang="fr-FR" smtClean="0"/>
-              <a:t>06/11/2024</a:t>
+              <a:t>09/10/2026</a:t>
             </a:fld>
             <a:endParaRPr lang="fr-FR"/>
           </a:p>
@@ -2842,7 +2848,7 @@
           <a:p>
             <a:fld id="{BC070D19-CEA5-4277-916F-A68997455471}" type="datetimeFigureOut">
               <a:rPr lang="fr-FR" smtClean="0"/>
-              <a:t>06/11/2024</a:t>
+              <a:t>09/10/2026</a:t>
             </a:fld>
             <a:endParaRPr lang="fr-FR"/>
           </a:p>
@@ -3012,7 +3018,7 @@
           <a:p>
             <a:fld id="{BC070D19-CEA5-4277-916F-A68997455471}" type="datetimeFigureOut">
               <a:rPr lang="fr-FR" smtClean="0"/>
-              <a:t>06/11/2024</a:t>
+              <a:t>09/10/2026</a:t>
             </a:fld>
             <a:endParaRPr lang="fr-FR"/>
           </a:p>
@@ -3192,7 +3198,7 @@
           <a:p>
             <a:fld id="{BC070D19-CEA5-4277-916F-A68997455471}" type="datetimeFigureOut">
               <a:rPr lang="fr-FR" smtClean="0"/>
-              <a:t>06/11/2024</a:t>
+              <a:t>09/10/2026</a:t>
             </a:fld>
             <a:endParaRPr lang="fr-FR"/>
           </a:p>
@@ -3362,7 +3368,7 @@
           <a:p>
             <a:fld id="{BC070D19-CEA5-4277-916F-A68997455471}" type="datetimeFigureOut">
               <a:rPr lang="fr-FR" smtClean="0"/>
-              <a:t>06/11/2024</a:t>
+              <a:t>09/10/2026</a:t>
             </a:fld>
             <a:endParaRPr lang="fr-FR"/>
           </a:p>
@@ -3619,7 +3625,7 @@
           <a:p>
             <a:fld id="{BC070D19-CEA5-4277-916F-A68997455471}" type="datetimeFigureOut">
               <a:rPr lang="fr-FR" smtClean="0"/>
-              <a:t>06/11/2024</a:t>
+              <a:t>09/10/2026</a:t>
             </a:fld>
             <a:endParaRPr lang="fr-FR"/>
           </a:p>
@@ -3851,7 +3857,7 @@
           <a:p>
             <a:fld id="{BC070D19-CEA5-4277-916F-A68997455471}" type="datetimeFigureOut">
               <a:rPr lang="fr-FR" smtClean="0"/>
-              <a:t>06/11/2024</a:t>
+              <a:t>09/10/2026</a:t>
             </a:fld>
             <a:endParaRPr lang="fr-FR"/>
           </a:p>
@@ -4244,7 +4250,7 @@
           <a:p>
             <a:fld id="{BC070D19-CEA5-4277-916F-A68997455471}" type="datetimeFigureOut">
               <a:rPr lang="fr-FR" smtClean="0"/>
-              <a:t>06/11/2024</a:t>
+              <a:t>09/10/2026</a:t>
             </a:fld>
             <a:endParaRPr lang="fr-FR"/>
           </a:p>
@@ -4362,7 +4368,7 @@
           <a:p>
             <a:fld id="{BC070D19-CEA5-4277-916F-A68997455471}" type="datetimeFigureOut">
               <a:rPr lang="fr-FR" smtClean="0"/>
-              <a:t>06/11/2024</a:t>
+              <a:t>09/10/2026</a:t>
             </a:fld>
             <a:endParaRPr lang="fr-FR"/>
           </a:p>
@@ -4457,7 +4463,7 @@
           <a:p>
             <a:fld id="{BC070D19-CEA5-4277-916F-A68997455471}" type="datetimeFigureOut">
               <a:rPr lang="fr-FR" smtClean="0"/>
-              <a:t>06/11/2024</a:t>
+              <a:t>09/10/2026</a:t>
             </a:fld>
             <a:endParaRPr lang="fr-FR"/>
           </a:p>
@@ -4730,7 +4736,7 @@
           <a:p>
             <a:fld id="{BC070D19-CEA5-4277-916F-A68997455471}" type="datetimeFigureOut">
               <a:rPr lang="fr-FR" smtClean="0"/>
-              <a:t>06/11/2024</a:t>
+              <a:t>09/10/2026</a:t>
             </a:fld>
             <a:endParaRPr lang="fr-FR"/>
           </a:p>
@@ -5011,7 +5017,7 @@
           <a:p>
             <a:fld id="{BC070D19-CEA5-4277-916F-A68997455471}" type="datetimeFigureOut">
               <a:rPr lang="fr-FR" smtClean="0"/>
-              <a:t>06/11/2024</a:t>
+              <a:t>09/10/2026</a:t>
             </a:fld>
             <a:endParaRPr lang="fr-FR"/>
           </a:p>
@@ -5251,7 +5257,7 @@
           <a:p>
             <a:fld id="{BC070D19-CEA5-4277-916F-A68997455471}" type="datetimeFigureOut">
               <a:rPr lang="fr-FR" smtClean="0"/>
-              <a:t>06/11/2024</a:t>
+              <a:t>09/10/2026</a:t>
             </a:fld>
             <a:endParaRPr lang="fr-FR"/>
           </a:p>
@@ -6067,7 +6073,7 @@
           <a:p>
             <a:pPr algn="r"/>
             <a:r>
-              <a:rPr lang="fr-FR" dirty="0">
+              <a:rPr lang="fr-FR" dirty="0" err="1">
                 <a:effectLst>
                   <a:outerShdw blurRad="50800" dist="38100" dir="2700000" algn="tl" rotWithShape="0">
                     <a:prstClr val="black">
@@ -6076,7 +6082,7 @@
                   </a:outerShdw>
                 </a:effectLst>
               </a:rPr>
-              <a:t>Developped</a:t>
+              <a:t>Developed</a:t>
             </a:r>
             <a:r>
               <a:rPr lang="fr-FR" dirty="0"/>
@@ -7051,7 +7057,7 @@
           <a:p>
             <a:pPr algn="r"/>
             <a:r>
-              <a:rPr lang="fr-FR" dirty="0">
+              <a:rPr lang="fr-FR" dirty="0" err="1">
                 <a:effectLst>
                   <a:outerShdw blurRad="50800" dist="38100" dir="2700000" algn="tl" rotWithShape="0">
                     <a:prstClr val="black">
@@ -7060,7 +7066,7 @@
                   </a:outerShdw>
                 </a:effectLst>
               </a:rPr>
-              <a:t>Developped</a:t>
+              <a:t>Developed</a:t>
             </a:r>
             <a:r>
               <a:rPr lang="fr-FR" dirty="0"/>
@@ -8035,7 +8041,7 @@
           <a:p>
             <a:pPr algn="r"/>
             <a:r>
-              <a:rPr lang="fr-FR" dirty="0">
+              <a:rPr lang="fr-FR" dirty="0" err="1">
                 <a:effectLst>
                   <a:outerShdw blurRad="50800" dist="38100" dir="2700000" algn="tl" rotWithShape="0">
                     <a:prstClr val="black">
@@ -8044,7 +8050,7 @@
                   </a:outerShdw>
                 </a:effectLst>
               </a:rPr>
-              <a:t>Developped</a:t>
+              <a:t>Developed</a:t>
             </a:r>
             <a:r>
               <a:rPr lang="fr-FR" dirty="0"/>
@@ -8739,6 +8745,1005 @@
     <p:extLst>
       <p:ext uri="{BB962C8B-B14F-4D97-AF65-F5344CB8AC3E}">
         <p14:creationId xmlns:p14="http://schemas.microsoft.com/office/powerpoint/2010/main" val="1133916633"/>
+      </p:ext>
+    </p:extLst>
+  </p:cSld>
+  <p:clrMapOvr>
+    <a:masterClrMapping/>
+  </p:clrMapOvr>
+</p:sld>
+</file>
+
+<file path=ppt/slides/slide4.xml><?xml version="1.0" encoding="utf-8"?>
+<p:sld xmlns:a="http://schemas.openxmlformats.org/drawingml/2006/main" xmlns:r="http://schemas.openxmlformats.org/officeDocument/2006/relationships" xmlns:p="http://schemas.openxmlformats.org/presentationml/2006/main">
+  <p:cSld>
+    <p:bg>
+      <p:bgPr>
+        <a:solidFill>
+          <a:schemeClr val="accent1">
+            <a:lumMod val="50000"/>
+          </a:schemeClr>
+        </a:solidFill>
+        <a:effectLst/>
+      </p:bgPr>
+    </p:bg>
+    <p:spTree>
+      <p:nvGrpSpPr>
+        <p:cNvPr id="1" name="">
+          <a:extLst>
+            <a:ext uri="{FF2B5EF4-FFF2-40B4-BE49-F238E27FC236}">
+              <a16:creationId xmlns:a16="http://schemas.microsoft.com/office/drawing/2014/main" id="{23633DFD-46B9-A26E-4E1F-E54EBAECE00B}"/>
+            </a:ext>
+          </a:extLst>
+        </p:cNvPr>
+        <p:cNvGrpSpPr/>
+        <p:nvPr/>
+      </p:nvGrpSpPr>
+      <p:grpSpPr>
+        <a:xfrm>
+          <a:off x="0" y="0"/>
+          <a:ext cx="0" cy="0"/>
+          <a:chOff x="0" y="0"/>
+          <a:chExt cx="0" cy="0"/>
+        </a:xfrm>
+      </p:grpSpPr>
+      <p:sp>
+        <p:nvSpPr>
+          <p:cNvPr id="4" name="Rectangle 3">
+            <a:extLst>
+              <a:ext uri="{FF2B5EF4-FFF2-40B4-BE49-F238E27FC236}">
+                <a16:creationId xmlns:a16="http://schemas.microsoft.com/office/drawing/2014/main" id="{0770F9E0-0665-8D4D-985F-96EB229C8F66}"/>
+              </a:ext>
+            </a:extLst>
+          </p:cNvPr>
+          <p:cNvSpPr/>
+          <p:nvPr/>
+        </p:nvSpPr>
+        <p:spPr>
+          <a:xfrm>
+            <a:off x="-9426" y="-94267"/>
+            <a:ext cx="12192000" cy="556181"/>
+          </a:xfrm>
+          <a:prstGeom prst="rect">
+            <a:avLst/>
+          </a:prstGeom>
+          <a:ln>
+            <a:noFill/>
+          </a:ln>
+        </p:spPr>
+        <p:style>
+          <a:lnRef idx="2">
+            <a:schemeClr val="accent1">
+              <a:shade val="50000"/>
+            </a:schemeClr>
+          </a:lnRef>
+          <a:fillRef idx="1">
+            <a:schemeClr val="accent1"/>
+          </a:fillRef>
+          <a:effectRef idx="0">
+            <a:schemeClr val="accent1"/>
+          </a:effectRef>
+          <a:fontRef idx="minor">
+            <a:schemeClr val="lt1"/>
+          </a:fontRef>
+        </p:style>
+        <p:txBody>
+          <a:bodyPr rtlCol="0" anchor="ctr"/>
+          <a:lstStyle/>
+          <a:p>
+            <a:pPr algn="ctr"/>
+            <a:endParaRPr lang="fr-FR" dirty="0">
+              <a:effectLst>
+                <a:outerShdw blurRad="50800" dist="38100" dir="2700000" algn="tl" rotWithShape="0">
+                  <a:prstClr val="black">
+                    <a:alpha val="40000"/>
+                  </a:prstClr>
+                </a:outerShdw>
+              </a:effectLst>
+            </a:endParaRPr>
+          </a:p>
+        </p:txBody>
+      </p:sp>
+      <p:sp>
+        <p:nvSpPr>
+          <p:cNvPr id="5" name="Rectangle 4">
+            <a:extLst>
+              <a:ext uri="{FF2B5EF4-FFF2-40B4-BE49-F238E27FC236}">
+                <a16:creationId xmlns:a16="http://schemas.microsoft.com/office/drawing/2014/main" id="{8B51F9A2-3583-310B-870C-32ABDE4720AB}"/>
+              </a:ext>
+            </a:extLst>
+          </p:cNvPr>
+          <p:cNvSpPr/>
+          <p:nvPr/>
+        </p:nvSpPr>
+        <p:spPr>
+          <a:xfrm>
+            <a:off x="0" y="6301819"/>
+            <a:ext cx="12192000" cy="556181"/>
+          </a:xfrm>
+          <a:prstGeom prst="rect">
+            <a:avLst/>
+          </a:prstGeom>
+          <a:gradFill flip="none" rotWithShape="1">
+            <a:gsLst>
+              <a:gs pos="0">
+                <a:schemeClr val="accent1"/>
+              </a:gs>
+              <a:gs pos="100000">
+                <a:srgbClr val="112D31"/>
+              </a:gs>
+            </a:gsLst>
+            <a:lin ang="0" scaled="1"/>
+            <a:tileRect/>
+          </a:gradFill>
+          <a:ln>
+            <a:noFill/>
+          </a:ln>
+        </p:spPr>
+        <p:style>
+          <a:lnRef idx="2">
+            <a:schemeClr val="accent1">
+              <a:shade val="50000"/>
+            </a:schemeClr>
+          </a:lnRef>
+          <a:fillRef idx="1">
+            <a:schemeClr val="accent1"/>
+          </a:fillRef>
+          <a:effectRef idx="0">
+            <a:schemeClr val="accent1"/>
+          </a:effectRef>
+          <a:fontRef idx="minor">
+            <a:schemeClr val="lt1"/>
+          </a:fontRef>
+        </p:style>
+        <p:txBody>
+          <a:bodyPr rtlCol="0" anchor="ctr"/>
+          <a:lstStyle/>
+          <a:p>
+            <a:pPr algn="ctr"/>
+            <a:endParaRPr lang="fr-FR"/>
+          </a:p>
+        </p:txBody>
+      </p:sp>
+      <p:sp>
+        <p:nvSpPr>
+          <p:cNvPr id="7" name="Rectangle 6">
+            <a:extLst>
+              <a:ext uri="{FF2B5EF4-FFF2-40B4-BE49-F238E27FC236}">
+                <a16:creationId xmlns:a16="http://schemas.microsoft.com/office/drawing/2014/main" id="{F3841450-FAC2-A021-EC8D-F80D2AC340F2}"/>
+              </a:ext>
+            </a:extLst>
+          </p:cNvPr>
+          <p:cNvSpPr/>
+          <p:nvPr/>
+        </p:nvSpPr>
+        <p:spPr>
+          <a:xfrm>
+            <a:off x="0" y="6229819"/>
+            <a:ext cx="12192000" cy="72000"/>
+          </a:xfrm>
+          <a:prstGeom prst="rect">
+            <a:avLst/>
+          </a:prstGeom>
+          <a:gradFill flip="none" rotWithShape="1">
+            <a:gsLst>
+              <a:gs pos="0">
+                <a:schemeClr val="accent1"/>
+              </a:gs>
+              <a:gs pos="100000">
+                <a:srgbClr val="112D31"/>
+              </a:gs>
+            </a:gsLst>
+            <a:lin ang="10800000" scaled="1"/>
+            <a:tileRect/>
+          </a:gradFill>
+          <a:ln>
+            <a:noFill/>
+          </a:ln>
+        </p:spPr>
+        <p:style>
+          <a:lnRef idx="2">
+            <a:schemeClr val="accent1">
+              <a:shade val="50000"/>
+            </a:schemeClr>
+          </a:lnRef>
+          <a:fillRef idx="1">
+            <a:schemeClr val="accent1"/>
+          </a:fillRef>
+          <a:effectRef idx="0">
+            <a:schemeClr val="accent1"/>
+          </a:effectRef>
+          <a:fontRef idx="minor">
+            <a:schemeClr val="lt1"/>
+          </a:fontRef>
+        </p:style>
+        <p:txBody>
+          <a:bodyPr rtlCol="0" anchor="ctr"/>
+          <a:lstStyle/>
+          <a:p>
+            <a:pPr algn="ctr"/>
+            <a:endParaRPr lang="fr-FR"/>
+          </a:p>
+        </p:txBody>
+      </p:sp>
+      <p:sp>
+        <p:nvSpPr>
+          <p:cNvPr id="8" name="ZoneTexte 7">
+            <a:extLst>
+              <a:ext uri="{FF2B5EF4-FFF2-40B4-BE49-F238E27FC236}">
+                <a16:creationId xmlns:a16="http://schemas.microsoft.com/office/drawing/2014/main" id="{086D064C-7252-3950-7C7C-6A6077182D9D}"/>
+              </a:ext>
+            </a:extLst>
+          </p:cNvPr>
+          <p:cNvSpPr txBox="1"/>
+          <p:nvPr/>
+        </p:nvSpPr>
+        <p:spPr>
+          <a:xfrm flipH="1">
+            <a:off x="-18853" y="1761"/>
+            <a:ext cx="3233394" cy="461665"/>
+          </a:xfrm>
+          <a:prstGeom prst="rect">
+            <a:avLst/>
+          </a:prstGeom>
+          <a:noFill/>
+        </p:spPr>
+        <p:txBody>
+          <a:bodyPr wrap="square" rtlCol="0">
+            <a:spAutoFit/>
+          </a:bodyPr>
+          <a:lstStyle/>
+          <a:p>
+            <a:r>
+              <a:rPr lang="fr-FR" sz="2400" dirty="0" err="1"/>
+              <a:t>Problem</a:t>
+            </a:r>
+            <a:r>
+              <a:rPr lang="fr-FR" sz="2400" dirty="0"/>
+              <a:t> </a:t>
+            </a:r>
+            <a:r>
+              <a:rPr lang="fr-FR" sz="2400"/>
+              <a:t>Statement</a:t>
+            </a:r>
+            <a:endParaRPr lang="fr-FR" sz="2400" dirty="0"/>
+          </a:p>
+        </p:txBody>
+      </p:sp>
+      <p:sp>
+        <p:nvSpPr>
+          <p:cNvPr id="9" name="ZoneTexte 8">
+            <a:extLst>
+              <a:ext uri="{FF2B5EF4-FFF2-40B4-BE49-F238E27FC236}">
+                <a16:creationId xmlns:a16="http://schemas.microsoft.com/office/drawing/2014/main" id="{80F74CEC-65F0-A2EE-8907-D4EE20C6F119}"/>
+              </a:ext>
+            </a:extLst>
+          </p:cNvPr>
+          <p:cNvSpPr txBox="1"/>
+          <p:nvPr/>
+        </p:nvSpPr>
+        <p:spPr>
+          <a:xfrm>
+            <a:off x="9051303" y="6380259"/>
+            <a:ext cx="3121844" cy="369332"/>
+          </a:xfrm>
+          <a:prstGeom prst="rect">
+            <a:avLst/>
+          </a:prstGeom>
+          <a:noFill/>
+        </p:spPr>
+        <p:txBody>
+          <a:bodyPr wrap="square" rtlCol="0">
+            <a:spAutoFit/>
+          </a:bodyPr>
+          <a:lstStyle/>
+          <a:p>
+            <a:pPr algn="r"/>
+            <a:r>
+              <a:rPr lang="fr-FR" dirty="0" err="1">
+                <a:effectLst>
+                  <a:outerShdw blurRad="50800" dist="38100" dir="2700000" algn="tl" rotWithShape="0">
+                    <a:prstClr val="black">
+                      <a:alpha val="40000"/>
+                    </a:prstClr>
+                  </a:outerShdw>
+                </a:effectLst>
+              </a:rPr>
+              <a:t>Developed</a:t>
+            </a:r>
+            <a:r>
+              <a:rPr lang="fr-FR" dirty="0"/>
+              <a:t> by Carine FOTSO</a:t>
+            </a:r>
+          </a:p>
+        </p:txBody>
+      </p:sp>
+      <p:sp>
+        <p:nvSpPr>
+          <p:cNvPr id="17" name="Forme libre : forme 16">
+            <a:extLst>
+              <a:ext uri="{FF2B5EF4-FFF2-40B4-BE49-F238E27FC236}">
+                <a16:creationId xmlns:a16="http://schemas.microsoft.com/office/drawing/2014/main" id="{1DD7C843-A740-6E5D-9E4B-65F946033A85}"/>
+              </a:ext>
+            </a:extLst>
+          </p:cNvPr>
+          <p:cNvSpPr/>
+          <p:nvPr/>
+        </p:nvSpPr>
+        <p:spPr>
+          <a:xfrm rot="13326028">
+            <a:off x="4433140" y="-963785"/>
+            <a:ext cx="2569149" cy="2631822"/>
+          </a:xfrm>
+          <a:custGeom>
+            <a:avLst/>
+            <a:gdLst>
+              <a:gd name="connsiteX0" fmla="*/ 1755382 w 2569149"/>
+              <a:gd name="connsiteY0" fmla="*/ 1484908 h 2631822"/>
+              <a:gd name="connsiteX1" fmla="*/ 486088 w 2569149"/>
+              <a:gd name="connsiteY1" fmla="*/ 2631822 h 2631822"/>
+              <a:gd name="connsiteX2" fmla="*/ 376693 w 2569149"/>
+              <a:gd name="connsiteY2" fmla="*/ 2599201 h 2631822"/>
+              <a:gd name="connsiteX3" fmla="*/ 65392 w 2569149"/>
+              <a:gd name="connsiteY3" fmla="*/ 2397578 h 2631822"/>
+              <a:gd name="connsiteX4" fmla="*/ 0 w 2569149"/>
+              <a:gd name="connsiteY4" fmla="*/ 2321443 h 2631822"/>
+              <a:gd name="connsiteX5" fmla="*/ 2569149 w 2569149"/>
+              <a:gd name="connsiteY5" fmla="*/ 0 h 2631822"/>
+              <a:gd name="connsiteX6" fmla="*/ 2428393 w 2569149"/>
+              <a:gd name="connsiteY6" fmla="*/ 150355 h 2631822"/>
+              <a:gd name="connsiteX7" fmla="*/ 1793684 w 2569149"/>
+              <a:gd name="connsiteY7" fmla="*/ 1280335 h 2631822"/>
+            </a:gdLst>
+            <a:ahLst/>
+            <a:cxnLst>
+              <a:cxn ang="0">
+                <a:pos x="connsiteX0" y="connsiteY0"/>
+              </a:cxn>
+              <a:cxn ang="0">
+                <a:pos x="connsiteX1" y="connsiteY1"/>
+              </a:cxn>
+              <a:cxn ang="0">
+                <a:pos x="connsiteX2" y="connsiteY2"/>
+              </a:cxn>
+              <a:cxn ang="0">
+                <a:pos x="connsiteX3" y="connsiteY3"/>
+              </a:cxn>
+              <a:cxn ang="0">
+                <a:pos x="connsiteX4" y="connsiteY4"/>
+              </a:cxn>
+              <a:cxn ang="0">
+                <a:pos x="connsiteX5" y="connsiteY5"/>
+              </a:cxn>
+              <a:cxn ang="0">
+                <a:pos x="connsiteX6" y="connsiteY6"/>
+              </a:cxn>
+              <a:cxn ang="0">
+                <a:pos x="connsiteX7" y="connsiteY7"/>
+              </a:cxn>
+            </a:cxnLst>
+            <a:rect l="l" t="t" r="r" b="b"/>
+            <a:pathLst>
+              <a:path w="2569149" h="2631822">
+                <a:moveTo>
+                  <a:pt x="1755382" y="1484908"/>
+                </a:moveTo>
+                <a:lnTo>
+                  <a:pt x="486088" y="2631822"/>
+                </a:lnTo>
+                <a:lnTo>
+                  <a:pt x="376693" y="2599201"/>
+                </a:lnTo>
+                <a:cubicBezTo>
+                  <a:pt x="259524" y="2551593"/>
+                  <a:pt x="154007" y="2482704"/>
+                  <a:pt x="65392" y="2397578"/>
+                </a:cubicBezTo>
+                <a:lnTo>
+                  <a:pt x="0" y="2321443"/>
+                </a:lnTo>
+                <a:lnTo>
+                  <a:pt x="2569149" y="0"/>
+                </a:lnTo>
+                <a:lnTo>
+                  <a:pt x="2428393" y="150355"/>
+                </a:lnTo>
+                <a:cubicBezTo>
+                  <a:pt x="2099285" y="527015"/>
+                  <a:pt x="1887715" y="903675"/>
+                  <a:pt x="1793684" y="1280335"/>
+                </a:cubicBezTo>
+                <a:close/>
+              </a:path>
+            </a:pathLst>
+          </a:custGeom>
+          <a:solidFill>
+            <a:srgbClr val="B3DFE5">
+              <a:alpha val="69804"/>
+            </a:srgbClr>
+          </a:solidFill>
+        </p:spPr>
+        <p:style>
+          <a:lnRef idx="2">
+            <a:schemeClr val="accent1">
+              <a:shade val="50000"/>
+            </a:schemeClr>
+          </a:lnRef>
+          <a:fillRef idx="1">
+            <a:schemeClr val="accent1"/>
+          </a:fillRef>
+          <a:effectRef idx="0">
+            <a:schemeClr val="accent1"/>
+          </a:effectRef>
+          <a:fontRef idx="minor">
+            <a:schemeClr val="lt1"/>
+          </a:fontRef>
+        </p:style>
+        <p:txBody>
+          <a:bodyPr wrap="square" rtlCol="0" anchor="ctr">
+            <a:noAutofit/>
+          </a:bodyPr>
+          <a:lstStyle/>
+          <a:p>
+            <a:pPr algn="ctr"/>
+            <a:endParaRPr lang="fr-FR"/>
+          </a:p>
+        </p:txBody>
+      </p:sp>
+      <p:sp>
+        <p:nvSpPr>
+          <p:cNvPr id="18" name="Forme libre : forme 17">
+            <a:extLst>
+              <a:ext uri="{FF2B5EF4-FFF2-40B4-BE49-F238E27FC236}">
+                <a16:creationId xmlns:a16="http://schemas.microsoft.com/office/drawing/2014/main" id="{C1507CCA-0F9F-C5E3-43EB-2457DBC72B8F}"/>
+              </a:ext>
+            </a:extLst>
+          </p:cNvPr>
+          <p:cNvSpPr/>
+          <p:nvPr/>
+        </p:nvSpPr>
+        <p:spPr>
+          <a:xfrm rot="13326028">
+            <a:off x="6038955" y="-964642"/>
+            <a:ext cx="2569149" cy="2631822"/>
+          </a:xfrm>
+          <a:custGeom>
+            <a:avLst/>
+            <a:gdLst>
+              <a:gd name="connsiteX0" fmla="*/ 1755382 w 2569149"/>
+              <a:gd name="connsiteY0" fmla="*/ 1484908 h 2631822"/>
+              <a:gd name="connsiteX1" fmla="*/ 486088 w 2569149"/>
+              <a:gd name="connsiteY1" fmla="*/ 2631822 h 2631822"/>
+              <a:gd name="connsiteX2" fmla="*/ 376693 w 2569149"/>
+              <a:gd name="connsiteY2" fmla="*/ 2599201 h 2631822"/>
+              <a:gd name="connsiteX3" fmla="*/ 65392 w 2569149"/>
+              <a:gd name="connsiteY3" fmla="*/ 2397578 h 2631822"/>
+              <a:gd name="connsiteX4" fmla="*/ 0 w 2569149"/>
+              <a:gd name="connsiteY4" fmla="*/ 2321443 h 2631822"/>
+              <a:gd name="connsiteX5" fmla="*/ 2569149 w 2569149"/>
+              <a:gd name="connsiteY5" fmla="*/ 0 h 2631822"/>
+              <a:gd name="connsiteX6" fmla="*/ 2428393 w 2569149"/>
+              <a:gd name="connsiteY6" fmla="*/ 150355 h 2631822"/>
+              <a:gd name="connsiteX7" fmla="*/ 1793684 w 2569149"/>
+              <a:gd name="connsiteY7" fmla="*/ 1280335 h 2631822"/>
+            </a:gdLst>
+            <a:ahLst/>
+            <a:cxnLst>
+              <a:cxn ang="0">
+                <a:pos x="connsiteX0" y="connsiteY0"/>
+              </a:cxn>
+              <a:cxn ang="0">
+                <a:pos x="connsiteX1" y="connsiteY1"/>
+              </a:cxn>
+              <a:cxn ang="0">
+                <a:pos x="connsiteX2" y="connsiteY2"/>
+              </a:cxn>
+              <a:cxn ang="0">
+                <a:pos x="connsiteX3" y="connsiteY3"/>
+              </a:cxn>
+              <a:cxn ang="0">
+                <a:pos x="connsiteX4" y="connsiteY4"/>
+              </a:cxn>
+              <a:cxn ang="0">
+                <a:pos x="connsiteX5" y="connsiteY5"/>
+              </a:cxn>
+              <a:cxn ang="0">
+                <a:pos x="connsiteX6" y="connsiteY6"/>
+              </a:cxn>
+              <a:cxn ang="0">
+                <a:pos x="connsiteX7" y="connsiteY7"/>
+              </a:cxn>
+            </a:cxnLst>
+            <a:rect l="l" t="t" r="r" b="b"/>
+            <a:pathLst>
+              <a:path w="2569149" h="2631822">
+                <a:moveTo>
+                  <a:pt x="1755382" y="1484908"/>
+                </a:moveTo>
+                <a:lnTo>
+                  <a:pt x="486088" y="2631822"/>
+                </a:lnTo>
+                <a:lnTo>
+                  <a:pt x="376693" y="2599201"/>
+                </a:lnTo>
+                <a:cubicBezTo>
+                  <a:pt x="259524" y="2551593"/>
+                  <a:pt x="154007" y="2482704"/>
+                  <a:pt x="65392" y="2397578"/>
+                </a:cubicBezTo>
+                <a:lnTo>
+                  <a:pt x="0" y="2321443"/>
+                </a:lnTo>
+                <a:lnTo>
+                  <a:pt x="2569149" y="0"/>
+                </a:lnTo>
+                <a:lnTo>
+                  <a:pt x="2428393" y="150355"/>
+                </a:lnTo>
+                <a:cubicBezTo>
+                  <a:pt x="2099285" y="527015"/>
+                  <a:pt x="1887715" y="903675"/>
+                  <a:pt x="1793684" y="1280335"/>
+                </a:cubicBezTo>
+                <a:close/>
+              </a:path>
+            </a:pathLst>
+          </a:custGeom>
+          <a:solidFill>
+            <a:srgbClr val="8DCFD8">
+              <a:alpha val="69804"/>
+            </a:srgbClr>
+          </a:solidFill>
+        </p:spPr>
+        <p:style>
+          <a:lnRef idx="2">
+            <a:schemeClr val="accent1">
+              <a:shade val="50000"/>
+            </a:schemeClr>
+          </a:lnRef>
+          <a:fillRef idx="1">
+            <a:schemeClr val="accent1"/>
+          </a:fillRef>
+          <a:effectRef idx="0">
+            <a:schemeClr val="accent1"/>
+          </a:effectRef>
+          <a:fontRef idx="minor">
+            <a:schemeClr val="lt1"/>
+          </a:fontRef>
+        </p:style>
+        <p:txBody>
+          <a:bodyPr wrap="square" rtlCol="0" anchor="ctr">
+            <a:noAutofit/>
+          </a:bodyPr>
+          <a:lstStyle/>
+          <a:p>
+            <a:pPr algn="ctr"/>
+            <a:endParaRPr lang="fr-FR"/>
+          </a:p>
+        </p:txBody>
+      </p:sp>
+      <p:sp>
+        <p:nvSpPr>
+          <p:cNvPr id="19" name="Forme libre : forme 18">
+            <a:extLst>
+              <a:ext uri="{FF2B5EF4-FFF2-40B4-BE49-F238E27FC236}">
+                <a16:creationId xmlns:a16="http://schemas.microsoft.com/office/drawing/2014/main" id="{0CB255F1-C051-AD59-193C-C4ADFF73BEBB}"/>
+              </a:ext>
+            </a:extLst>
+          </p:cNvPr>
+          <p:cNvSpPr/>
+          <p:nvPr/>
+        </p:nvSpPr>
+        <p:spPr>
+          <a:xfrm rot="13326028">
+            <a:off x="7644771" y="-963788"/>
+            <a:ext cx="2569149" cy="2631822"/>
+          </a:xfrm>
+          <a:custGeom>
+            <a:avLst/>
+            <a:gdLst>
+              <a:gd name="connsiteX0" fmla="*/ 1755382 w 2569149"/>
+              <a:gd name="connsiteY0" fmla="*/ 1484908 h 2631822"/>
+              <a:gd name="connsiteX1" fmla="*/ 486088 w 2569149"/>
+              <a:gd name="connsiteY1" fmla="*/ 2631822 h 2631822"/>
+              <a:gd name="connsiteX2" fmla="*/ 376693 w 2569149"/>
+              <a:gd name="connsiteY2" fmla="*/ 2599201 h 2631822"/>
+              <a:gd name="connsiteX3" fmla="*/ 65392 w 2569149"/>
+              <a:gd name="connsiteY3" fmla="*/ 2397578 h 2631822"/>
+              <a:gd name="connsiteX4" fmla="*/ 0 w 2569149"/>
+              <a:gd name="connsiteY4" fmla="*/ 2321443 h 2631822"/>
+              <a:gd name="connsiteX5" fmla="*/ 2569149 w 2569149"/>
+              <a:gd name="connsiteY5" fmla="*/ 0 h 2631822"/>
+              <a:gd name="connsiteX6" fmla="*/ 2428393 w 2569149"/>
+              <a:gd name="connsiteY6" fmla="*/ 150355 h 2631822"/>
+              <a:gd name="connsiteX7" fmla="*/ 1793684 w 2569149"/>
+              <a:gd name="connsiteY7" fmla="*/ 1280335 h 2631822"/>
+            </a:gdLst>
+            <a:ahLst/>
+            <a:cxnLst>
+              <a:cxn ang="0">
+                <a:pos x="connsiteX0" y="connsiteY0"/>
+              </a:cxn>
+              <a:cxn ang="0">
+                <a:pos x="connsiteX1" y="connsiteY1"/>
+              </a:cxn>
+              <a:cxn ang="0">
+                <a:pos x="connsiteX2" y="connsiteY2"/>
+              </a:cxn>
+              <a:cxn ang="0">
+                <a:pos x="connsiteX3" y="connsiteY3"/>
+              </a:cxn>
+              <a:cxn ang="0">
+                <a:pos x="connsiteX4" y="connsiteY4"/>
+              </a:cxn>
+              <a:cxn ang="0">
+                <a:pos x="connsiteX5" y="connsiteY5"/>
+              </a:cxn>
+              <a:cxn ang="0">
+                <a:pos x="connsiteX6" y="connsiteY6"/>
+              </a:cxn>
+              <a:cxn ang="0">
+                <a:pos x="connsiteX7" y="connsiteY7"/>
+              </a:cxn>
+            </a:cxnLst>
+            <a:rect l="l" t="t" r="r" b="b"/>
+            <a:pathLst>
+              <a:path w="2569149" h="2631822">
+                <a:moveTo>
+                  <a:pt x="1755382" y="1484908"/>
+                </a:moveTo>
+                <a:lnTo>
+                  <a:pt x="486088" y="2631822"/>
+                </a:lnTo>
+                <a:lnTo>
+                  <a:pt x="376693" y="2599201"/>
+                </a:lnTo>
+                <a:cubicBezTo>
+                  <a:pt x="259524" y="2551593"/>
+                  <a:pt x="154007" y="2482704"/>
+                  <a:pt x="65392" y="2397578"/>
+                </a:cubicBezTo>
+                <a:lnTo>
+                  <a:pt x="0" y="2321443"/>
+                </a:lnTo>
+                <a:lnTo>
+                  <a:pt x="2569149" y="0"/>
+                </a:lnTo>
+                <a:lnTo>
+                  <a:pt x="2428393" y="150355"/>
+                </a:lnTo>
+                <a:cubicBezTo>
+                  <a:pt x="2099285" y="527015"/>
+                  <a:pt x="1887715" y="903675"/>
+                  <a:pt x="1793684" y="1280335"/>
+                </a:cubicBezTo>
+                <a:close/>
+              </a:path>
+            </a:pathLst>
+          </a:custGeom>
+          <a:solidFill>
+            <a:srgbClr val="31828E">
+              <a:alpha val="69804"/>
+            </a:srgbClr>
+          </a:solidFill>
+        </p:spPr>
+        <p:style>
+          <a:lnRef idx="2">
+            <a:schemeClr val="accent1">
+              <a:shade val="50000"/>
+            </a:schemeClr>
+          </a:lnRef>
+          <a:fillRef idx="1">
+            <a:schemeClr val="accent1"/>
+          </a:fillRef>
+          <a:effectRef idx="0">
+            <a:schemeClr val="accent1"/>
+          </a:effectRef>
+          <a:fontRef idx="minor">
+            <a:schemeClr val="lt1"/>
+          </a:fontRef>
+        </p:style>
+        <p:txBody>
+          <a:bodyPr wrap="square" rtlCol="0" anchor="ctr">
+            <a:noAutofit/>
+          </a:bodyPr>
+          <a:lstStyle/>
+          <a:p>
+            <a:pPr algn="ctr"/>
+            <a:endParaRPr lang="fr-FR"/>
+          </a:p>
+        </p:txBody>
+      </p:sp>
+      <p:sp>
+        <p:nvSpPr>
+          <p:cNvPr id="20" name="Forme libre : forme 19">
+            <a:extLst>
+              <a:ext uri="{FF2B5EF4-FFF2-40B4-BE49-F238E27FC236}">
+                <a16:creationId xmlns:a16="http://schemas.microsoft.com/office/drawing/2014/main" id="{1E0877B5-04BF-308F-7AC9-0024314BB489}"/>
+              </a:ext>
+            </a:extLst>
+          </p:cNvPr>
+          <p:cNvSpPr/>
+          <p:nvPr/>
+        </p:nvSpPr>
+        <p:spPr>
+          <a:xfrm rot="13326028">
+            <a:off x="9250587" y="-954360"/>
+            <a:ext cx="2569149" cy="2631822"/>
+          </a:xfrm>
+          <a:custGeom>
+            <a:avLst/>
+            <a:gdLst>
+              <a:gd name="connsiteX0" fmla="*/ 1755382 w 2569149"/>
+              <a:gd name="connsiteY0" fmla="*/ 1484908 h 2631822"/>
+              <a:gd name="connsiteX1" fmla="*/ 486088 w 2569149"/>
+              <a:gd name="connsiteY1" fmla="*/ 2631822 h 2631822"/>
+              <a:gd name="connsiteX2" fmla="*/ 376693 w 2569149"/>
+              <a:gd name="connsiteY2" fmla="*/ 2599201 h 2631822"/>
+              <a:gd name="connsiteX3" fmla="*/ 65392 w 2569149"/>
+              <a:gd name="connsiteY3" fmla="*/ 2397578 h 2631822"/>
+              <a:gd name="connsiteX4" fmla="*/ 0 w 2569149"/>
+              <a:gd name="connsiteY4" fmla="*/ 2321443 h 2631822"/>
+              <a:gd name="connsiteX5" fmla="*/ 2569149 w 2569149"/>
+              <a:gd name="connsiteY5" fmla="*/ 0 h 2631822"/>
+              <a:gd name="connsiteX6" fmla="*/ 2428393 w 2569149"/>
+              <a:gd name="connsiteY6" fmla="*/ 150355 h 2631822"/>
+              <a:gd name="connsiteX7" fmla="*/ 1793684 w 2569149"/>
+              <a:gd name="connsiteY7" fmla="*/ 1280335 h 2631822"/>
+            </a:gdLst>
+            <a:ahLst/>
+            <a:cxnLst>
+              <a:cxn ang="0">
+                <a:pos x="connsiteX0" y="connsiteY0"/>
+              </a:cxn>
+              <a:cxn ang="0">
+                <a:pos x="connsiteX1" y="connsiteY1"/>
+              </a:cxn>
+              <a:cxn ang="0">
+                <a:pos x="connsiteX2" y="connsiteY2"/>
+              </a:cxn>
+              <a:cxn ang="0">
+                <a:pos x="connsiteX3" y="connsiteY3"/>
+              </a:cxn>
+              <a:cxn ang="0">
+                <a:pos x="connsiteX4" y="connsiteY4"/>
+              </a:cxn>
+              <a:cxn ang="0">
+                <a:pos x="connsiteX5" y="connsiteY5"/>
+              </a:cxn>
+              <a:cxn ang="0">
+                <a:pos x="connsiteX6" y="connsiteY6"/>
+              </a:cxn>
+              <a:cxn ang="0">
+                <a:pos x="connsiteX7" y="connsiteY7"/>
+              </a:cxn>
+            </a:cxnLst>
+            <a:rect l="l" t="t" r="r" b="b"/>
+            <a:pathLst>
+              <a:path w="2569149" h="2631822">
+                <a:moveTo>
+                  <a:pt x="1755382" y="1484908"/>
+                </a:moveTo>
+                <a:lnTo>
+                  <a:pt x="486088" y="2631822"/>
+                </a:lnTo>
+                <a:lnTo>
+                  <a:pt x="376693" y="2599201"/>
+                </a:lnTo>
+                <a:cubicBezTo>
+                  <a:pt x="259524" y="2551593"/>
+                  <a:pt x="154007" y="2482704"/>
+                  <a:pt x="65392" y="2397578"/>
+                </a:cubicBezTo>
+                <a:lnTo>
+                  <a:pt x="0" y="2321443"/>
+                </a:lnTo>
+                <a:lnTo>
+                  <a:pt x="2569149" y="0"/>
+                </a:lnTo>
+                <a:lnTo>
+                  <a:pt x="2428393" y="150355"/>
+                </a:lnTo>
+                <a:cubicBezTo>
+                  <a:pt x="2099285" y="527015"/>
+                  <a:pt x="1887715" y="903675"/>
+                  <a:pt x="1793684" y="1280335"/>
+                </a:cubicBezTo>
+                <a:close/>
+              </a:path>
+            </a:pathLst>
+          </a:custGeom>
+          <a:solidFill>
+            <a:srgbClr val="20575F">
+              <a:alpha val="69804"/>
+            </a:srgbClr>
+          </a:solidFill>
+        </p:spPr>
+        <p:style>
+          <a:lnRef idx="2">
+            <a:schemeClr val="accent1">
+              <a:shade val="50000"/>
+            </a:schemeClr>
+          </a:lnRef>
+          <a:fillRef idx="1">
+            <a:schemeClr val="accent1"/>
+          </a:fillRef>
+          <a:effectRef idx="0">
+            <a:schemeClr val="accent1"/>
+          </a:effectRef>
+          <a:fontRef idx="minor">
+            <a:schemeClr val="lt1"/>
+          </a:fontRef>
+        </p:style>
+        <p:txBody>
+          <a:bodyPr wrap="square" rtlCol="0" anchor="ctr">
+            <a:noAutofit/>
+          </a:bodyPr>
+          <a:lstStyle/>
+          <a:p>
+            <a:pPr algn="ctr"/>
+            <a:endParaRPr lang="fr-FR"/>
+          </a:p>
+        </p:txBody>
+      </p:sp>
+      <p:sp>
+        <p:nvSpPr>
+          <p:cNvPr id="6" name="Rectangle 5">
+            <a:extLst>
+              <a:ext uri="{FF2B5EF4-FFF2-40B4-BE49-F238E27FC236}">
+                <a16:creationId xmlns:a16="http://schemas.microsoft.com/office/drawing/2014/main" id="{2D40F91C-ABD8-7A0D-BC21-FF204C7995FC}"/>
+              </a:ext>
+            </a:extLst>
+          </p:cNvPr>
+          <p:cNvSpPr/>
+          <p:nvPr/>
+        </p:nvSpPr>
+        <p:spPr>
+          <a:xfrm>
+            <a:off x="-18853" y="395924"/>
+            <a:ext cx="12192000" cy="72000"/>
+          </a:xfrm>
+          <a:prstGeom prst="rect">
+            <a:avLst/>
+          </a:prstGeom>
+          <a:gradFill flip="none" rotWithShape="1">
+            <a:gsLst>
+              <a:gs pos="0">
+                <a:schemeClr val="accent1"/>
+              </a:gs>
+              <a:gs pos="100000">
+                <a:srgbClr val="112D31"/>
+              </a:gs>
+            </a:gsLst>
+            <a:lin ang="0" scaled="1"/>
+            <a:tileRect/>
+          </a:gradFill>
+          <a:ln>
+            <a:noFill/>
+          </a:ln>
+        </p:spPr>
+        <p:style>
+          <a:lnRef idx="2">
+            <a:schemeClr val="accent1">
+              <a:shade val="50000"/>
+            </a:schemeClr>
+          </a:lnRef>
+          <a:fillRef idx="1">
+            <a:schemeClr val="accent1"/>
+          </a:fillRef>
+          <a:effectRef idx="0">
+            <a:schemeClr val="accent1"/>
+          </a:effectRef>
+          <a:fontRef idx="minor">
+            <a:schemeClr val="lt1"/>
+          </a:fontRef>
+        </p:style>
+        <p:txBody>
+          <a:bodyPr rtlCol="0" anchor="ctr"/>
+          <a:lstStyle/>
+          <a:p>
+            <a:pPr algn="ctr"/>
+            <a:endParaRPr lang="fr-FR"/>
+          </a:p>
+        </p:txBody>
+      </p:sp>
+      <p:sp>
+        <p:nvSpPr>
+          <p:cNvPr id="21" name="ZoneTexte 20">
+            <a:extLst>
+              <a:ext uri="{FF2B5EF4-FFF2-40B4-BE49-F238E27FC236}">
+                <a16:creationId xmlns:a16="http://schemas.microsoft.com/office/drawing/2014/main" id="{5E204D52-D01C-0421-91DF-8D46D39B5F24}"/>
+              </a:ext>
+            </a:extLst>
+          </p:cNvPr>
+          <p:cNvSpPr txBox="1"/>
+          <p:nvPr/>
+        </p:nvSpPr>
+        <p:spPr>
+          <a:xfrm>
+            <a:off x="9529779" y="-37879"/>
+            <a:ext cx="2469823" cy="369332"/>
+          </a:xfrm>
+          <a:prstGeom prst="rect">
+            <a:avLst/>
+          </a:prstGeom>
+          <a:noFill/>
+        </p:spPr>
+        <p:txBody>
+          <a:bodyPr wrap="square" rtlCol="0">
+            <a:spAutoFit/>
+          </a:bodyPr>
+          <a:lstStyle/>
+          <a:p>
+            <a:r>
+              <a:rPr lang="fr-FR" b="1" dirty="0">
+                <a:effectLst>
+                  <a:glow rad="88900">
+                    <a:schemeClr val="accent6">
+                      <a:lumMod val="75000"/>
+                      <a:alpha val="30000"/>
+                    </a:schemeClr>
+                  </a:glow>
+                  <a:reflection blurRad="6350" stA="50000" endA="300" endPos="37000" dist="25400" dir="5400000" sy="-100000" algn="bl" rotWithShape="0"/>
+                </a:effectLst>
+                <a:latin typeface="Bodoni MT Black" panose="02070A03080606020203" pitchFamily="18" charset="0"/>
+              </a:rPr>
+              <a:t>MARKET  MINDZ</a:t>
+            </a:r>
+          </a:p>
+        </p:txBody>
+      </p:sp>
+      <p:pic>
+        <p:nvPicPr>
+          <p:cNvPr id="23" name="Graphique 22" descr="Éclair avec un remplissage uni">
+            <a:extLst>
+              <a:ext uri="{FF2B5EF4-FFF2-40B4-BE49-F238E27FC236}">
+                <a16:creationId xmlns:a16="http://schemas.microsoft.com/office/drawing/2014/main" id="{42707FF2-AED5-6A3F-FCF0-5D0FAD84BEE8}"/>
+              </a:ext>
+            </a:extLst>
+          </p:cNvPr>
+          <p:cNvPicPr>
+            <a:picLocks noChangeAspect="1"/>
+          </p:cNvPicPr>
+          <p:nvPr/>
+        </p:nvPicPr>
+        <p:blipFill>
+          <a:blip r:embed="rId2">
+            <a:extLst>
+              <a:ext uri="{28A0092B-C50C-407E-A947-70E740481C1C}">
+                <a14:useLocalDpi xmlns:a14="http://schemas.microsoft.com/office/drawing/2010/main" val="0"/>
+              </a:ext>
+              <a:ext uri="{96DAC541-7B7A-43D3-8B79-37D633B846F1}">
+                <asvg:svgBlip xmlns:asvg="http://schemas.microsoft.com/office/drawing/2016/SVG/main" r:embed="rId3"/>
+              </a:ext>
+            </a:extLst>
+          </a:blip>
+          <a:stretch>
+            <a:fillRect/>
+          </a:stretch>
+        </p:blipFill>
+        <p:spPr>
+          <a:xfrm>
+            <a:off x="10630300" y="-42055"/>
+            <a:ext cx="451756" cy="451756"/>
+          </a:xfrm>
+          <a:prstGeom prst="rect">
+            <a:avLst/>
+          </a:prstGeom>
+          <a:effectLst>
+            <a:glow rad="76200">
+              <a:schemeClr val="tx1">
+                <a:lumMod val="85000"/>
+                <a:alpha val="32000"/>
+              </a:schemeClr>
+            </a:glow>
+          </a:effectLst>
+        </p:spPr>
+      </p:pic>
+    </p:spTree>
+    <p:extLst>
+      <p:ext uri="{BB962C8B-B14F-4D97-AF65-F5344CB8AC3E}">
+        <p14:creationId xmlns:p14="http://schemas.microsoft.com/office/powerpoint/2010/main" val="2512376023"/>
       </p:ext>
     </p:extLst>
   </p:cSld>

</xml_diff>